<commit_message>
minor fixes to linux lessons
</commit_message>
<xml_diff>
--- a/Intro to Computers/Lesson 02 - Networking Basics/Lesson 2 - Network Basics.pptx
+++ b/Intro to Computers/Lesson 02 - Networking Basics/Lesson 2 - Network Basics.pptx
@@ -1279,7 +1279,7 @@
           <a:p>
             <a:fld id="{7A3E0868-4E26-4CDC-8A56-D70E2D8B12FE}" type="datetime3">
               <a:rPr lang="en-US" smtClean="0"/>
-              <a:t>5 May 2026</a:t>
+              <a:t>1 June 2026</a:t>
             </a:fld>
             <a:endParaRPr lang="en-US"/>
           </a:p>
@@ -3856,7 +3856,7 @@
           <a:p>
             <a:fld id="{A7B8021B-6105-4216-96FC-94348F216D0E}" type="datetime3">
               <a:rPr lang="en-US" smtClean="0"/>
-              <a:t>5 May 2026</a:t>
+              <a:t>1 June 2026</a:t>
             </a:fld>
             <a:endParaRPr lang="en-US"/>
           </a:p>
@@ -5554,7 +5554,7 @@
           <a:p>
             <a:fld id="{5D27CFAB-73E6-44A8-B862-B3306344E3F2}" type="datetime3">
               <a:rPr lang="en-US" smtClean="0"/>
-              <a:t>5 May 2026</a:t>
+              <a:t>1 June 2026</a:t>
             </a:fld>
             <a:endParaRPr lang="en-US"/>
           </a:p>
@@ -7345,7 +7345,7 @@
           <a:p>
             <a:fld id="{A9B2E784-A5F5-4301-881B-94AC8DBF9DED}" type="datetime3">
               <a:rPr lang="en-US" smtClean="0"/>
-              <a:t>5 May 2026</a:t>
+              <a:t>1 June 2026</a:t>
             </a:fld>
             <a:endParaRPr lang="en-US"/>
           </a:p>
@@ -7525,7 +7525,7 @@
           <a:p>
             <a:fld id="{18EAB3A5-9E92-4BB9-8F22-9632B4FBEDBA}" type="datetime3">
               <a:rPr lang="en-US" smtClean="0"/>
-              <a:t>5 May 2026</a:t>
+              <a:t>1 June 2026</a:t>
             </a:fld>
             <a:endParaRPr lang="en-US"/>
           </a:p>
@@ -7753,7 +7753,7 @@
           <a:p>
             <a:fld id="{40923810-5FB2-48C9-96CA-1DE2C4773142}" type="datetime3">
               <a:rPr lang="en-US" smtClean="0"/>
-              <a:t>5 May 2026</a:t>
+              <a:t>1 June 2026</a:t>
             </a:fld>
             <a:endParaRPr lang="en-US"/>
           </a:p>
@@ -8044,7 +8044,7 @@
           <a:p>
             <a:fld id="{E50EFF4B-86EB-42FB-93EA-7D8F9CB2466F}" type="datetime3">
               <a:rPr lang="en-US" smtClean="0"/>
-              <a:t>5 May 2026</a:t>
+              <a:t>1 June 2026</a:t>
             </a:fld>
             <a:endParaRPr lang="en-US"/>
           </a:p>
@@ -8657,7 +8657,7 @@
           <a:p>
             <a:fld id="{FB14FC24-E041-45E9-9A72-E5755A86890F}" type="datetime3">
               <a:rPr lang="en-US" smtClean="0"/>
-              <a:t>5 May 2026</a:t>
+              <a:t>1 June 2026</a:t>
             </a:fld>
             <a:endParaRPr lang="en-US"/>
           </a:p>
@@ -9518,7 +9518,7 @@
           <a:p>
             <a:fld id="{98A19125-94A7-4474-858C-FD9C4ABE9DDA}" type="datetime3">
               <a:rPr lang="en-US" smtClean="0"/>
-              <a:t>5 May 2026</a:t>
+              <a:t>1 June 2026</a:t>
             </a:fld>
             <a:endParaRPr lang="en-US"/>
           </a:p>
@@ -10622,7 +10622,7 @@
           <a:p>
             <a:fld id="{3BA0343D-C8D8-43CE-BB79-50DEA219DB07}" type="datetime3">
               <a:rPr lang="en-US" smtClean="0"/>
-              <a:t>5 May 2026</a:t>
+              <a:t>1 June 2026</a:t>
             </a:fld>
             <a:endParaRPr lang="en-US"/>
           </a:p>
@@ -10912,7 +10912,7 @@
           <a:p>
             <a:fld id="{453BD212-0B9F-4987-965F-AC83B2FC354F}" type="datetime3">
               <a:rPr lang="en-US" smtClean="0"/>
-              <a:t>5 May 2026</a:t>
+              <a:t>1 June 2026</a:t>
             </a:fld>
             <a:endParaRPr lang="en-US"/>
           </a:p>
@@ -11156,7 +11156,7 @@
           <a:p>
             <a:fld id="{6DDC931E-8CBE-4A3F-A034-9B6122C6DCDB}" type="datetime3">
               <a:rPr lang="en-US" smtClean="0"/>
-              <a:t>5 May 2026</a:t>
+              <a:t>1 June 2026</a:t>
             </a:fld>
             <a:endParaRPr lang="en-US"/>
           </a:p>
@@ -12939,7 +12939,7 @@
           <a:p>
             <a:fld id="{220AF9C2-5E8A-4308-AE6B-CA9B65007D0E}" type="datetime3">
               <a:rPr lang="en-US" smtClean="0"/>
-              <a:t>5 May 2026</a:t>
+              <a:t>1 June 2026</a:t>
             </a:fld>
             <a:endParaRPr lang="en-US"/>
           </a:p>
@@ -13253,7 +13253,7 @@
           <a:p>
             <a:fld id="{FF31E861-D2AF-431D-860B-DCF67C218052}" type="datetime3">
               <a:rPr lang="en-US" smtClean="0"/>
-              <a:t>5 May 2026</a:t>
+              <a:t>1 June 2026</a:t>
             </a:fld>
             <a:endParaRPr lang="en-US"/>
           </a:p>
@@ -13533,7 +13533,7 @@
           <a:p>
             <a:fld id="{D1DA25B2-AAF1-4C1F-AA38-12D5BFA7D4C8}" type="datetime3">
               <a:rPr lang="en-US" smtClean="0"/>
-              <a:t>5 May 2026</a:t>
+              <a:t>1 June 2026</a:t>
             </a:fld>
             <a:endParaRPr lang="en-US"/>
           </a:p>
@@ -13813,7 +13813,7 @@
           <a:p>
             <a:fld id="{A25C0F39-45D0-48E9-90B3-7FE8FCE561C8}" type="datetime3">
               <a:rPr lang="en-US" smtClean="0"/>
-              <a:t>5 May 2026</a:t>
+              <a:t>1 June 2026</a:t>
             </a:fld>
             <a:endParaRPr lang="en-US"/>
           </a:p>
@@ -14315,7 +14315,7 @@
           <a:p>
             <a:fld id="{9BAF1A3D-92FA-4F24-9781-74AFA516A230}" type="datetime3">
               <a:rPr lang="en-US" smtClean="0"/>
-              <a:t>5 May 2026</a:t>
+              <a:t>1 June 2026</a:t>
             </a:fld>
             <a:endParaRPr lang="en-US"/>
           </a:p>
@@ -14443,7 +14443,7 @@
           <a:p>
             <a:fld id="{5719C672-856D-4617-A693-8FE15749A9B7}" type="datetime3">
               <a:rPr lang="en-US" smtClean="0"/>
-              <a:t>5 May 2026</a:t>
+              <a:t>1 June 2026</a:t>
             </a:fld>
             <a:endParaRPr lang="en-US"/>
           </a:p>
@@ -14579,7 +14579,7 @@
           <a:p>
             <a:fld id="{5F6C764D-A39E-4C03-B161-E0BC66E8883B}" type="datetime3">
               <a:rPr lang="en-US" smtClean="0"/>
-              <a:t>5 May 2026</a:t>
+              <a:t>1 June 2026</a:t>
             </a:fld>
             <a:endParaRPr lang="en-US"/>
           </a:p>
@@ -14818,7 +14818,7 @@
           <a:p>
             <a:fld id="{6E3E33F9-20B7-4995-BE7D-165DBB597850}" type="datetime3">
               <a:rPr lang="en-US" smtClean="0"/>
-              <a:t>5 May 2026</a:t>
+              <a:t>1 June 2026</a:t>
             </a:fld>
             <a:endParaRPr lang="en-US"/>
           </a:p>
@@ -14932,7 +14932,7 @@
           <a:p>
             <a:fld id="{CD41C263-3501-4369-A962-62B6BF915CDE}" type="datetime3">
               <a:rPr lang="en-US" smtClean="0"/>
-              <a:t>5 May 2026</a:t>
+              <a:t>1 June 2026</a:t>
             </a:fld>
             <a:endParaRPr lang="en-US"/>
           </a:p>
@@ -15336,7 +15336,7 @@
           <a:p>
             <a:fld id="{B06F3EBE-B2E8-4992-9F00-9E4B44F057C0}" type="datetime3">
               <a:rPr lang="en-US" smtClean="0"/>
-              <a:t>5 May 2026</a:t>
+              <a:t>1 June 2026</a:t>
             </a:fld>
             <a:endParaRPr lang="en-US"/>
           </a:p>
@@ -15469,7 +15469,7 @@
           <a:p>
             <a:fld id="{D41656AB-D2E1-472E-8B95-0DF5C6E1D623}" type="datetime3">
               <a:rPr lang="en-US" smtClean="0"/>
-              <a:t>5 May 2026</a:t>
+              <a:t>1 June 2026</a:t>
             </a:fld>
             <a:endParaRPr lang="en-US"/>
           </a:p>
@@ -17377,7 +17377,7 @@
           <a:p>
             <a:fld id="{AD622D1A-DF83-41A8-85FF-04D90BF831D3}" type="datetime3">
               <a:rPr lang="en-US" smtClean="0"/>
-              <a:t>5 May 2026</a:t>
+              <a:t>1 June 2026</a:t>
             </a:fld>
             <a:endParaRPr lang="en-US"/>
           </a:p>
@@ -17628,7 +17628,7 @@
           <a:p>
             <a:fld id="{334F72C3-CDF3-44A8-B602-1649B1728485}" type="datetime3">
               <a:rPr lang="en-US" smtClean="0"/>
-              <a:t>5 May 2026</a:t>
+              <a:t>1 June 2026</a:t>
             </a:fld>
             <a:endParaRPr lang="en-US"/>
           </a:p>
@@ -17936,7 +17936,7 @@
           <a:p>
             <a:fld id="{1E0132BA-B5E7-4FFD-AF6C-169169D47D4A}" type="datetime3">
               <a:rPr lang="en-US" smtClean="0"/>
-              <a:t>5 May 2026</a:t>
+              <a:t>1 June 2026</a:t>
             </a:fld>
             <a:endParaRPr lang="en-US"/>
           </a:p>
@@ -18418,7 +18418,7 @@
           <a:p>
             <a:fld id="{81A30091-1C2A-4151-8D3C-D1E47A72615F}" type="datetime3">
               <a:rPr lang="en-US" smtClean="0"/>
-              <a:t>5 May 2026</a:t>
+              <a:t>1 June 2026</a:t>
             </a:fld>
             <a:endParaRPr lang="en-US"/>
           </a:p>
@@ -19056,7 +19056,7 @@
           <a:p>
             <a:fld id="{35D703CE-07B4-4C05-A488-B4566700621F}" type="datetime3">
               <a:rPr lang="en-US" smtClean="0"/>
-              <a:t>5 May 2026</a:t>
+              <a:t>1 June 2026</a:t>
             </a:fld>
             <a:endParaRPr lang="en-US"/>
           </a:p>
@@ -20115,7 +20115,7 @@
           <a:p>
             <a:fld id="{694BD61C-20BA-43AF-A21F-1DAFB3200099}" type="datetime3">
               <a:rPr lang="en-US" smtClean="0"/>
-              <a:t>5 May 2026</a:t>
+              <a:t>1 June 2026</a:t>
             </a:fld>
             <a:endParaRPr lang="en-US"/>
           </a:p>
@@ -20604,7 +20604,7 @@
           <a:p>
             <a:fld id="{CABCB1B0-B6E5-4DD1-BB55-95C076D6C0C8}" type="datetime3">
               <a:rPr lang="en-US" smtClean="0"/>
-              <a:t>5 May 2026</a:t>
+              <a:t>1 June 2026</a:t>
             </a:fld>
             <a:endParaRPr lang="en-US"/>
           </a:p>
@@ -21155,7 +21155,7 @@
           <a:p>
             <a:fld id="{7A3E0868-4E26-4CDC-8A56-D70E2D8B12FE}" type="datetime3">
               <a:rPr lang="en-US" smtClean="0"/>
-              <a:t>5 May 2026</a:t>
+              <a:t>1 June 2026</a:t>
             </a:fld>
             <a:endParaRPr lang="en-US"/>
           </a:p>
@@ -22142,12 +22142,12 @@
                         <a:buNone/>
                       </a:pPr>
                       <a:r>
-                        <a:rPr lang="en-US" sz="1100">
+                        <a:rPr lang="en-US" sz="1100" dirty="0">
                           <a:latin typeface="Courier New" panose="02070309020205020404" pitchFamily="49" charset="0"/>
                         </a:rPr>
                         <a:t>169.254.0.0/16</a:t>
                       </a:r>
-                      <a:endParaRPr lang="en-US" sz="1100"/>
+                      <a:endParaRPr lang="en-US" sz="1100" dirty="0"/>
                     </a:p>
                   </a:txBody>
                   <a:tcPr marL="78377" marR="78377" marT="39189" marB="39189" anchor="ctr">
@@ -22468,12 +22468,12 @@
                         <a:buNone/>
                       </a:pPr>
                       <a:r>
-                        <a:rPr lang="en-US" sz="1100">
+                        <a:rPr lang="en-US" sz="1100" dirty="0">
                           <a:latin typeface="Courier New" panose="02070309020205020404" pitchFamily="49" charset="0"/>
                         </a:rPr>
                         <a:t>192.88.99.0/24</a:t>
                       </a:r>
-                      <a:endParaRPr lang="en-US" sz="1100"/>
+                      <a:endParaRPr lang="en-US" sz="1100" dirty="0"/>
                     </a:p>
                   </a:txBody>
                   <a:tcPr marL="78377" marR="78377" marT="39189" marB="39189" anchor="ctr">
@@ -24029,7 +24029,7 @@
             <p:ph sz="half" idx="1"/>
             <p:extLst>
               <p:ext uri="{D42A27DB-BD31-4B8C-83A1-F6EECF244321}">
-                <p14:modId xmlns:p14="http://schemas.microsoft.com/office/powerpoint/2010/main" val="1579534716"/>
+                <p14:modId xmlns:p14="http://schemas.microsoft.com/office/powerpoint/2010/main" val="539039856"/>
               </p:ext>
             </p:extLst>
           </p:nvPr>
@@ -24334,12 +24334,12 @@
                         <a:buNone/>
                       </a:pPr>
                       <a:r>
-                        <a:rPr lang="en-US" sz="900" b="1">
+                        <a:rPr lang="en-US" sz="900" b="1" dirty="0">
                           <a:effectLst/>
                         </a:rPr>
                         <a:t>Same App, Multiple Connections</a:t>
                       </a:r>
-                      <a:endParaRPr lang="en-US" sz="900">
+                      <a:endParaRPr lang="en-US" sz="900" dirty="0">
                         <a:effectLst/>
                       </a:endParaRPr>
                     </a:p>
@@ -24581,7 +24581,7 @@
                       <a:pPr algn="l">
                         <a:buNone/>
                       </a:pPr>
-                      <a:endParaRPr lang="en-US" sz="900">
+                      <a:endParaRPr lang="en-US" sz="900" dirty="0">
                         <a:effectLst/>
                       </a:endParaRPr>
                     </a:p>
@@ -24680,7 +24680,7 @@
                         <a:buNone/>
                       </a:pPr>
                       <a:r>
-                        <a:rPr lang="en-US" sz="900">
+                        <a:rPr lang="en-US" sz="900" dirty="0">
                           <a:effectLst/>
                         </a:rPr>
                         <a:t>49153</a:t>
@@ -24749,7 +24749,7 @@
                         <a:buNone/>
                       </a:pPr>
                       <a:r>
-                        <a:rPr lang="en-US" sz="900">
+                        <a:rPr lang="en-US" sz="900" dirty="0">
                           <a:effectLst/>
                         </a:rPr>
                         <a:t>443</a:t>
@@ -24824,12 +24824,12 @@
                         <a:buNone/>
                       </a:pPr>
                       <a:r>
-                        <a:rPr lang="en-US" sz="900" b="1">
+                        <a:rPr lang="en-US" sz="900" b="1" dirty="0">
                           <a:effectLst/>
                         </a:rPr>
                         <a:t>Different Protocols</a:t>
                       </a:r>
-                      <a:endParaRPr lang="en-US" sz="900">
+                      <a:endParaRPr lang="en-US" sz="900" dirty="0">
                         <a:effectLst/>
                       </a:endParaRPr>
                     </a:p>
@@ -24891,7 +24891,7 @@
                         <a:buNone/>
                       </a:pPr>
                       <a:r>
-                        <a:rPr lang="en-US" sz="900">
+                        <a:rPr lang="en-US" sz="900" dirty="0">
                           <a:effectLst/>
                         </a:rPr>
                         <a:t>192.168.1.10</a:t>
@@ -25314,12 +25314,30 @@
                         <a:buNone/>
                       </a:pPr>
                       <a:r>
-                        <a:rPr lang="fr-FR" sz="900" b="1">
+                        <a:rPr lang="fr-FR" sz="900" b="1" dirty="0" err="1">
                           <a:effectLst/>
                         </a:rPr>
-                        <a:t>Same Dest Port, Different Services</a:t>
+                        <a:t>Same</a:t>
                       </a:r>
-                      <a:endParaRPr lang="fr-FR" sz="900">
+                      <a:r>
+                        <a:rPr lang="fr-FR" sz="900" b="1" dirty="0">
+                          <a:effectLst/>
+                        </a:rPr>
+                        <a:t> Dest IP, </a:t>
+                      </a:r>
+                      <a:r>
+                        <a:rPr lang="fr-FR" sz="900" b="1" dirty="0" err="1">
+                          <a:effectLst/>
+                        </a:rPr>
+                        <a:t>Different</a:t>
+                      </a:r>
+                      <a:r>
+                        <a:rPr lang="fr-FR" sz="900" b="1" dirty="0">
+                          <a:effectLst/>
+                        </a:rPr>
+                        <a:t> Services</a:t>
+                      </a:r>
+                      <a:endParaRPr lang="fr-FR" sz="900" dirty="0">
                         <a:effectLst/>
                       </a:endParaRPr>
                     </a:p>
@@ -25660,7 +25678,7 @@
                         <a:buNone/>
                       </a:pPr>
                       <a:r>
-                        <a:rPr lang="en-US" sz="900">
+                        <a:rPr lang="en-US" sz="900" dirty="0">
                           <a:effectLst/>
                         </a:rPr>
                         <a:t>52002</a:t>
@@ -29271,7 +29289,7 @@
             <a:pPr lvl="1"/>
             <a:r>
               <a:rPr lang="en-US" dirty="0"/>
-              <a:t>Port numbers and application management</a:t>
+              <a:t>Explain port numbers and application management</a:t>
             </a:r>
           </a:p>
           <a:p>
@@ -31896,7 +31914,7 @@
                 <a:latin typeface="Courier New" panose="02070309020205020404" pitchFamily="49" charset="0"/>
                 <a:cs typeface="Courier New" panose="02070309020205020404" pitchFamily="49" charset="0"/>
               </a:rPr>
-              <a:t>172. 20. 10.  5  /14</a:t>
+              <a:t>172. 22. 10.  5  /14</a:t>
             </a:r>
           </a:p>
           <a:p>
@@ -31953,10 +31971,20 @@
             </a:r>
             <a:r>
               <a:rPr lang="en-US" dirty="0">
+                <a:solidFill>
+                  <a:srgbClr val="221F20"/>
+                </a:solidFill>
                 <a:latin typeface="Courier New" panose="02070309020205020404" pitchFamily="49" charset="0"/>
                 <a:cs typeface="Courier New" panose="02070309020205020404" pitchFamily="49" charset="0"/>
               </a:rPr>
-              <a:t>00 00000000 00000000 (network addy)</a:t>
+              <a:t>1</a:t>
+            </a:r>
+            <a:r>
+              <a:rPr lang="en-US" dirty="0">
+                <a:latin typeface="Courier New" panose="02070309020205020404" pitchFamily="49" charset="0"/>
+                <a:cs typeface="Courier New" panose="02070309020205020404" pitchFamily="49" charset="0"/>
+              </a:rPr>
+              <a:t>0 00000000 00000000 (network addy)</a:t>
             </a:r>
           </a:p>
           <a:p>
@@ -32016,7 +32044,7 @@
                 <a:latin typeface="Courier New" panose="02070309020205020404" pitchFamily="49" charset="0"/>
                 <a:cs typeface="Courier New" panose="02070309020205020404" pitchFamily="49" charset="0"/>
               </a:rPr>
-              <a:t>172.20.10.5</a:t>
+              <a:t>172.22.10.5</a:t>
             </a:r>
           </a:p>
           <a:p>
@@ -32075,7 +32103,7 @@
                 <a:latin typeface="Courier New" panose="02070309020205020404" pitchFamily="49" charset="0"/>
                 <a:cs typeface="Courier New" panose="02070309020205020404" pitchFamily="49" charset="0"/>
               </a:rPr>
-              <a:t>172. 22.  5.  9  /14</a:t>
+              <a:t>172. 20.  5.  9  /14</a:t>
             </a:r>
           </a:p>
           <a:p>
@@ -32246,7 +32274,7 @@
                 <a:latin typeface="Courier New" panose="02070309020205020404" pitchFamily="49" charset="0"/>
                 <a:cs typeface="Courier New" panose="02070309020205020404" pitchFamily="49" charset="0"/>
               </a:rPr>
-              <a:t>172. 22.  5.  9  /14</a:t>
+              <a:t>172. 22. 10.  5  /14</a:t>
             </a:r>
           </a:p>
           <a:p>
@@ -32259,7 +32287,7 @@
                 <a:latin typeface="Courier New" panose="02070309020205020404" pitchFamily="49" charset="0"/>
                 <a:cs typeface="Courier New" panose="02070309020205020404" pitchFamily="49" charset="0"/>
               </a:rPr>
-              <a:t>172. 20. 10.  5  /14</a:t>
+              <a:t>172. 20.  5.  9  /14</a:t>
             </a:r>
           </a:p>
           <a:p>

</xml_diff>